<commit_message>
Record successful GitHub Actions evidence
</commit_message>
<xml_diff>
--- a/session21-python/submission/CampusFix-Capstone-Deck.pptx
+++ b/session21-python/submission/CampusFix-Capstone-Deck.pptx
@@ -2,21 +2,21 @@
 <file path=ppt/presentation.xml><?xml version="1.0" encoding="utf-8"?>
 <p:presentation xmlns:p="http://schemas.openxmlformats.org/presentationml/2006/main">
   <p:sldMasterIdLst>
-    <p:sldMasterId xmlns:r="http://schemas.openxmlformats.org/officeDocument/2006/relationships" id="2147483648" r:id="R857b2243dfee4a47"/>
+    <p:sldMasterId xmlns:r="http://schemas.openxmlformats.org/officeDocument/2006/relationships" id="2147483648" r:id="R95a8ec4e7bd34178"/>
   </p:sldMasterIdLst>
   <p:notesMasterIdLst>
-    <p:notesMasterId xmlns:r="http://schemas.openxmlformats.org/officeDocument/2006/relationships" r:id="R06ffd9ba8a764ff4"/>
+    <p:notesMasterId xmlns:r="http://schemas.openxmlformats.org/officeDocument/2006/relationships" r:id="R904cabaf72c840e9"/>
   </p:notesMasterIdLst>
   <p:sldIdLst>
-    <p:sldId xmlns:r="http://schemas.openxmlformats.org/officeDocument/2006/relationships" id="256" r:id="R796d052a98124326"/>
-    <p:sldId xmlns:r="http://schemas.openxmlformats.org/officeDocument/2006/relationships" id="257" r:id="R839a675930064078"/>
-    <p:sldId xmlns:r="http://schemas.openxmlformats.org/officeDocument/2006/relationships" id="258" r:id="R8f6d82acd4be46b3"/>
-    <p:sldId xmlns:r="http://schemas.openxmlformats.org/officeDocument/2006/relationships" id="259" r:id="R1a517e3c185047a3"/>
-    <p:sldId xmlns:r="http://schemas.openxmlformats.org/officeDocument/2006/relationships" id="260" r:id="Rc7960ecedc17425f"/>
-    <p:sldId xmlns:r="http://schemas.openxmlformats.org/officeDocument/2006/relationships" id="261" r:id="R192410f4ed394384"/>
-    <p:sldId xmlns:r="http://schemas.openxmlformats.org/officeDocument/2006/relationships" id="262" r:id="Reaf12194233e452a"/>
-    <p:sldId xmlns:r="http://schemas.openxmlformats.org/officeDocument/2006/relationships" id="263" r:id="R85b8b80a33f745fe"/>
-    <p:sldId xmlns:r="http://schemas.openxmlformats.org/officeDocument/2006/relationships" id="264" r:id="R2759b26485794ef6"/>
+    <p:sldId xmlns:r="http://schemas.openxmlformats.org/officeDocument/2006/relationships" id="256" r:id="Rd04606e82f9d4968"/>
+    <p:sldId xmlns:r="http://schemas.openxmlformats.org/officeDocument/2006/relationships" id="257" r:id="R203bcf91248c44ce"/>
+    <p:sldId xmlns:r="http://schemas.openxmlformats.org/officeDocument/2006/relationships" id="258" r:id="Rbcdd733fde224155"/>
+    <p:sldId xmlns:r="http://schemas.openxmlformats.org/officeDocument/2006/relationships" id="259" r:id="R406b3d4764d047d5"/>
+    <p:sldId xmlns:r="http://schemas.openxmlformats.org/officeDocument/2006/relationships" id="260" r:id="R58a350e7187c48ac"/>
+    <p:sldId xmlns:r="http://schemas.openxmlformats.org/officeDocument/2006/relationships" id="261" r:id="Rdda65acd595a4a69"/>
+    <p:sldId xmlns:r="http://schemas.openxmlformats.org/officeDocument/2006/relationships" id="262" r:id="R69872275003d422a"/>
+    <p:sldId xmlns:r="http://schemas.openxmlformats.org/officeDocument/2006/relationships" id="263" r:id="Rdaf8ea296bea4f52"/>
+    <p:sldId xmlns:r="http://schemas.openxmlformats.org/officeDocument/2006/relationships" id="264" r:id="R808b592911db4609"/>
   </p:sldIdLst>
   <p:sldSz cx="12192000" cy="6858000"/>
   <p:notesSz cx="6858000" cy="9144000"/>
@@ -1010,7 +1010,7 @@
           <a:lstStyle xmlns:a="http://schemas.openxmlformats.org/drawingml/2006/main"/>
           <a:p xmlns:a="http://schemas.openxmlformats.org/drawingml/2006/main">
             <a:r>
-              <a:t>Recording guide, about 25 seconds: close by stating exactly what is done and what remains. Terraform configuration is validated, but the AWS account and infrastructure have not been set up. Do not say AWS or the GitHub pipeline is complete. The instructor expects the M10 demo to show a pushed change, pipeline run, and deployment update once those are available. End by inviting questions.</a:t>
+              <a:t>Recording guide, about 25 seconds: show the verified CI run and describe what it proves. Run #4 on commit ba32c7a succeeded. Backend tests, frontend build, both Trivy scans, and GHCR publication of public SHA-tagged images passed. No findings matched the configured HIGH/CRITICAL gate. Deployment skipped because this workflow deploys only from main. AWS resources are not provisioned yet. After connecting the personal account, record the Terraform plan, provision EKS, deploy with Helm, and show the rollout.</a:t>
             </a:r>
           </a:p>
         </p:txBody>
@@ -1108,6 +1108,7 @@
                 <a:spcPts val="0"/>
               </a:spcAft>
               <a:buNone/>
+              <a:defRPr/>
             </a:lvl1pPr>
             <a:lvl2pPr marL="0" indent="0">
               <a:lnSpc>
@@ -1120,6 +1121,7 @@
                 <a:spcPts val="0"/>
               </a:spcAft>
               <a:buNone/>
+              <a:defRPr/>
             </a:lvl2pPr>
             <a:lvl3pPr marL="0" indent="0">
               <a:lnSpc>
@@ -1132,6 +1134,7 @@
                 <a:spcPts val="0"/>
               </a:spcAft>
               <a:buNone/>
+              <a:defRPr/>
             </a:lvl3pPr>
             <a:lvl4pPr marL="0" indent="0">
               <a:lnSpc>
@@ -1144,6 +1147,7 @@
                 <a:spcPts val="0"/>
               </a:spcAft>
               <a:buNone/>
+              <a:defRPr/>
             </a:lvl4pPr>
             <a:lvl5pPr marL="0" indent="0">
               <a:lnSpc>
@@ -1156,6 +1160,7 @@
                 <a:spcPts val="0"/>
               </a:spcAft>
               <a:buNone/>
+              <a:defRPr/>
             </a:lvl5pPr>
             <a:lvl6pPr marL="0" indent="0">
               <a:lnSpc>
@@ -1168,6 +1173,7 @@
                 <a:spcPts val="0"/>
               </a:spcAft>
               <a:buNone/>
+              <a:defRPr/>
             </a:lvl6pPr>
             <a:lvl7pPr marL="0" indent="0">
               <a:lnSpc>
@@ -1180,6 +1186,7 @@
                 <a:spcPts val="0"/>
               </a:spcAft>
               <a:buNone/>
+              <a:defRPr/>
             </a:lvl7pPr>
             <a:lvl8pPr marL="0" indent="0">
               <a:lnSpc>
@@ -1192,6 +1199,7 @@
                 <a:spcPts val="0"/>
               </a:spcAft>
               <a:buNone/>
+              <a:defRPr/>
             </a:lvl8pPr>
             <a:lvl9pPr marL="0" indent="0">
               <a:lnSpc>
@@ -1204,6 +1212,7 @@
                 <a:spcPts val="0"/>
               </a:spcAft>
               <a:buNone/>
+              <a:defRPr/>
             </a:lvl9pPr>
           </a:lstStyle>
           <a:p xmlns:a="http://schemas.openxmlformats.org/drawingml/2006/main"/>
@@ -1265,6 +1274,7 @@
                 <a:spcPts val="0"/>
               </a:spcAft>
               <a:buNone/>
+              <a:defRPr/>
             </a:lvl1pPr>
             <a:lvl2pPr marL="0" indent="0">
               <a:lnSpc>
@@ -1277,6 +1287,7 @@
                 <a:spcPts val="0"/>
               </a:spcAft>
               <a:buNone/>
+              <a:defRPr/>
             </a:lvl2pPr>
             <a:lvl3pPr marL="0" indent="0">
               <a:lnSpc>
@@ -1289,6 +1300,7 @@
                 <a:spcPts val="0"/>
               </a:spcAft>
               <a:buNone/>
+              <a:defRPr/>
             </a:lvl3pPr>
             <a:lvl4pPr marL="0" indent="0">
               <a:lnSpc>
@@ -1301,6 +1313,7 @@
                 <a:spcPts val="0"/>
               </a:spcAft>
               <a:buNone/>
+              <a:defRPr/>
             </a:lvl4pPr>
             <a:lvl5pPr marL="0" indent="0">
               <a:lnSpc>
@@ -1313,6 +1326,7 @@
                 <a:spcPts val="0"/>
               </a:spcAft>
               <a:buNone/>
+              <a:defRPr/>
             </a:lvl5pPr>
             <a:lvl6pPr marL="0" indent="0">
               <a:lnSpc>
@@ -1325,6 +1339,7 @@
                 <a:spcPts val="0"/>
               </a:spcAft>
               <a:buNone/>
+              <a:defRPr/>
             </a:lvl6pPr>
             <a:lvl7pPr marL="0" indent="0">
               <a:lnSpc>
@@ -1337,6 +1352,7 @@
                 <a:spcPts val="0"/>
               </a:spcAft>
               <a:buNone/>
+              <a:defRPr/>
             </a:lvl7pPr>
             <a:lvl8pPr marL="0" indent="0">
               <a:lnSpc>
@@ -1349,6 +1365,7 @@
                 <a:spcPts val="0"/>
               </a:spcAft>
               <a:buNone/>
+              <a:defRPr/>
             </a:lvl8pPr>
             <a:lvl9pPr marL="0" indent="0">
               <a:lnSpc>
@@ -1361,6 +1378,7 @@
                 <a:spcPts val="0"/>
               </a:spcAft>
               <a:buNone/>
+              <a:defRPr/>
             </a:lvl9pPr>
           </a:lstStyle>
           <a:p xmlns:a="http://schemas.openxmlformats.org/drawingml/2006/main"/>
@@ -1439,6 +1457,7 @@
                 <a:spcPts val="0"/>
               </a:spcAft>
               <a:buNone/>
+              <a:defRPr/>
             </a:lvl1pPr>
             <a:lvl2pPr marL="0" indent="0">
               <a:lnSpc>
@@ -1451,6 +1470,7 @@
                 <a:spcPts val="0"/>
               </a:spcAft>
               <a:buNone/>
+              <a:defRPr/>
             </a:lvl2pPr>
             <a:lvl3pPr marL="0" indent="0">
               <a:lnSpc>
@@ -1463,6 +1483,7 @@
                 <a:spcPts val="0"/>
               </a:spcAft>
               <a:buNone/>
+              <a:defRPr/>
             </a:lvl3pPr>
             <a:lvl4pPr marL="0" indent="0">
               <a:lnSpc>
@@ -1475,6 +1496,7 @@
                 <a:spcPts val="0"/>
               </a:spcAft>
               <a:buNone/>
+              <a:defRPr/>
             </a:lvl4pPr>
             <a:lvl5pPr marL="0" indent="0">
               <a:lnSpc>
@@ -1487,6 +1509,7 @@
                 <a:spcPts val="0"/>
               </a:spcAft>
               <a:buNone/>
+              <a:defRPr/>
             </a:lvl5pPr>
             <a:lvl6pPr marL="0" indent="0">
               <a:lnSpc>
@@ -1499,6 +1522,7 @@
                 <a:spcPts val="0"/>
               </a:spcAft>
               <a:buNone/>
+              <a:defRPr/>
             </a:lvl6pPr>
             <a:lvl7pPr marL="0" indent="0">
               <a:lnSpc>
@@ -1511,6 +1535,7 @@
                 <a:spcPts val="0"/>
               </a:spcAft>
               <a:buNone/>
+              <a:defRPr/>
             </a:lvl7pPr>
             <a:lvl8pPr marL="0" indent="0">
               <a:lnSpc>
@@ -1523,6 +1548,7 @@
                 <a:spcPts val="0"/>
               </a:spcAft>
               <a:buNone/>
+              <a:defRPr/>
             </a:lvl8pPr>
             <a:lvl9pPr marL="0" indent="0">
               <a:lnSpc>
@@ -1535,6 +1561,7 @@
                 <a:spcPts val="0"/>
               </a:spcAft>
               <a:buNone/>
+              <a:defRPr/>
             </a:lvl9pPr>
           </a:lstStyle>
           <a:p xmlns:a="http://schemas.openxmlformats.org/drawingml/2006/main"/>
@@ -1613,6 +1640,7 @@
                 <a:spcPts val="0"/>
               </a:spcAft>
               <a:buNone/>
+              <a:defRPr/>
             </a:lvl1pPr>
             <a:lvl2pPr marL="0" indent="0">
               <a:lnSpc>
@@ -1625,6 +1653,7 @@
                 <a:spcPts val="0"/>
               </a:spcAft>
               <a:buNone/>
+              <a:defRPr/>
             </a:lvl2pPr>
             <a:lvl3pPr marL="0" indent="0">
               <a:lnSpc>
@@ -1637,6 +1666,7 @@
                 <a:spcPts val="0"/>
               </a:spcAft>
               <a:buNone/>
+              <a:defRPr/>
             </a:lvl3pPr>
             <a:lvl4pPr marL="0" indent="0">
               <a:lnSpc>
@@ -1649,6 +1679,7 @@
                 <a:spcPts val="0"/>
               </a:spcAft>
               <a:buNone/>
+              <a:defRPr/>
             </a:lvl4pPr>
             <a:lvl5pPr marL="0" indent="0">
               <a:lnSpc>
@@ -1661,6 +1692,7 @@
                 <a:spcPts val="0"/>
               </a:spcAft>
               <a:buNone/>
+              <a:defRPr/>
             </a:lvl5pPr>
             <a:lvl6pPr marL="0" indent="0">
               <a:lnSpc>
@@ -1673,6 +1705,7 @@
                 <a:spcPts val="0"/>
               </a:spcAft>
               <a:buNone/>
+              <a:defRPr/>
             </a:lvl6pPr>
             <a:lvl7pPr marL="0" indent="0">
               <a:lnSpc>
@@ -1685,6 +1718,7 @@
                 <a:spcPts val="0"/>
               </a:spcAft>
               <a:buNone/>
+              <a:defRPr/>
             </a:lvl7pPr>
             <a:lvl8pPr marL="0" indent="0">
               <a:lnSpc>
@@ -1697,6 +1731,7 @@
                 <a:spcPts val="0"/>
               </a:spcAft>
               <a:buNone/>
+              <a:defRPr/>
             </a:lvl8pPr>
             <a:lvl9pPr marL="0" indent="0">
               <a:lnSpc>
@@ -1709,6 +1744,7 @@
                 <a:spcPts val="0"/>
               </a:spcAft>
               <a:buNone/>
+              <a:defRPr/>
             </a:lvl9pPr>
           </a:lstStyle>
           <a:p xmlns:a="http://schemas.openxmlformats.org/drawingml/2006/main"/>
@@ -1770,6 +1806,7 @@
                 <a:spcPts val="1200"/>
               </a:spcAft>
               <a:buChar char="•"/>
+              <a:defRPr/>
             </a:lvl1pPr>
             <a:lvl2pPr marL="533400" indent="-228600">
               <a:lnSpc>
@@ -1782,6 +1819,7 @@
                 <a:spcPts val="1200"/>
               </a:spcAft>
               <a:buChar char="•"/>
+              <a:defRPr/>
             </a:lvl2pPr>
             <a:lvl3pPr marL="838200" indent="-228600">
               <a:lnSpc>
@@ -1794,6 +1832,7 @@
                 <a:spcPts val="1200"/>
               </a:spcAft>
               <a:buChar char="•"/>
+              <a:defRPr/>
             </a:lvl3pPr>
             <a:lvl4pPr marL="1143000" indent="-228600">
               <a:lnSpc>
@@ -1806,6 +1845,7 @@
                 <a:spcPts val="1200"/>
               </a:spcAft>
               <a:buChar char="•"/>
+              <a:defRPr/>
             </a:lvl4pPr>
             <a:lvl5pPr marL="1447800" indent="-228600">
               <a:lnSpc>
@@ -1818,6 +1858,7 @@
                 <a:spcPts val="1200"/>
               </a:spcAft>
               <a:buChar char="•"/>
+              <a:defRPr/>
             </a:lvl5pPr>
             <a:lvl6pPr marL="1752600" indent="-228600">
               <a:lnSpc>
@@ -1830,6 +1871,7 @@
                 <a:spcPts val="1200"/>
               </a:spcAft>
               <a:buChar char="•"/>
+              <a:defRPr/>
             </a:lvl6pPr>
             <a:lvl7pPr marL="2057400" indent="-228600">
               <a:lnSpc>
@@ -1842,6 +1884,7 @@
                 <a:spcPts val="1200"/>
               </a:spcAft>
               <a:buChar char="•"/>
+              <a:defRPr/>
             </a:lvl7pPr>
             <a:lvl8pPr marL="2362200" indent="-228600">
               <a:lnSpc>
@@ -1854,6 +1897,7 @@
                 <a:spcPts val="1200"/>
               </a:spcAft>
               <a:buChar char="•"/>
+              <a:defRPr/>
             </a:lvl8pPr>
             <a:lvl9pPr marL="2667000" indent="-228600">
               <a:lnSpc>
@@ -1866,6 +1910,7 @@
                 <a:spcPts val="1200"/>
               </a:spcAft>
               <a:buChar char="•"/>
+              <a:defRPr/>
             </a:lvl9pPr>
           </a:lstStyle>
           <a:p xmlns:a="http://schemas.openxmlformats.org/drawingml/2006/main"/>
@@ -1944,6 +1989,7 @@
                 <a:spcPts val="0"/>
               </a:spcAft>
               <a:buNone/>
+              <a:defRPr/>
             </a:lvl1pPr>
             <a:lvl2pPr marL="0" indent="0">
               <a:lnSpc>
@@ -1956,6 +2002,7 @@
                 <a:spcPts val="0"/>
               </a:spcAft>
               <a:buNone/>
+              <a:defRPr/>
             </a:lvl2pPr>
             <a:lvl3pPr marL="0" indent="0">
               <a:lnSpc>
@@ -1968,6 +2015,7 @@
                 <a:spcPts val="0"/>
               </a:spcAft>
               <a:buNone/>
+              <a:defRPr/>
             </a:lvl3pPr>
             <a:lvl4pPr marL="0" indent="0">
               <a:lnSpc>
@@ -1980,6 +2028,7 @@
                 <a:spcPts val="0"/>
               </a:spcAft>
               <a:buNone/>
+              <a:defRPr/>
             </a:lvl4pPr>
             <a:lvl5pPr marL="0" indent="0">
               <a:lnSpc>
@@ -1992,6 +2041,7 @@
                 <a:spcPts val="0"/>
               </a:spcAft>
               <a:buNone/>
+              <a:defRPr/>
             </a:lvl5pPr>
             <a:lvl6pPr marL="0" indent="0">
               <a:lnSpc>
@@ -2004,6 +2054,7 @@
                 <a:spcPts val="0"/>
               </a:spcAft>
               <a:buNone/>
+              <a:defRPr/>
             </a:lvl6pPr>
             <a:lvl7pPr marL="0" indent="0">
               <a:lnSpc>
@@ -2016,6 +2067,7 @@
                 <a:spcPts val="0"/>
               </a:spcAft>
               <a:buNone/>
+              <a:defRPr/>
             </a:lvl7pPr>
             <a:lvl8pPr marL="0" indent="0">
               <a:lnSpc>
@@ -2028,6 +2080,7 @@
                 <a:spcPts val="0"/>
               </a:spcAft>
               <a:buNone/>
+              <a:defRPr/>
             </a:lvl8pPr>
             <a:lvl9pPr marL="0" indent="0">
               <a:lnSpc>
@@ -2040,6 +2093,7 @@
                 <a:spcPts val="0"/>
               </a:spcAft>
               <a:buNone/>
+              <a:defRPr/>
             </a:lvl9pPr>
           </a:lstStyle>
           <a:p xmlns:a="http://schemas.openxmlformats.org/drawingml/2006/main"/>
@@ -2101,6 +2155,7 @@
                 <a:spcPts val="1200"/>
               </a:spcAft>
               <a:buChar char="•"/>
+              <a:defRPr/>
             </a:lvl1pPr>
             <a:lvl2pPr marL="533400" indent="-228600">
               <a:lnSpc>
@@ -2113,6 +2168,7 @@
                 <a:spcPts val="1200"/>
               </a:spcAft>
               <a:buChar char="•"/>
+              <a:defRPr/>
             </a:lvl2pPr>
             <a:lvl3pPr marL="838200" indent="-228600">
               <a:lnSpc>
@@ -2125,6 +2181,7 @@
                 <a:spcPts val="1200"/>
               </a:spcAft>
               <a:buChar char="•"/>
+              <a:defRPr/>
             </a:lvl3pPr>
             <a:lvl4pPr marL="1143000" indent="-228600">
               <a:lnSpc>
@@ -2137,6 +2194,7 @@
                 <a:spcPts val="1200"/>
               </a:spcAft>
               <a:buChar char="•"/>
+              <a:defRPr/>
             </a:lvl4pPr>
             <a:lvl5pPr marL="1447800" indent="-228600">
               <a:lnSpc>
@@ -2149,6 +2207,7 @@
                 <a:spcPts val="1200"/>
               </a:spcAft>
               <a:buChar char="•"/>
+              <a:defRPr/>
             </a:lvl5pPr>
             <a:lvl6pPr marL="1752600" indent="-228600">
               <a:lnSpc>
@@ -2161,6 +2220,7 @@
                 <a:spcPts val="1200"/>
               </a:spcAft>
               <a:buChar char="•"/>
+              <a:defRPr/>
             </a:lvl6pPr>
             <a:lvl7pPr marL="2057400" indent="-228600">
               <a:lnSpc>
@@ -2173,6 +2233,7 @@
                 <a:spcPts val="1200"/>
               </a:spcAft>
               <a:buChar char="•"/>
+              <a:defRPr/>
             </a:lvl7pPr>
             <a:lvl8pPr marL="2362200" indent="-228600">
               <a:lnSpc>
@@ -2185,6 +2246,7 @@
                 <a:spcPts val="1200"/>
               </a:spcAft>
               <a:buChar char="•"/>
+              <a:defRPr/>
             </a:lvl8pPr>
             <a:lvl9pPr marL="2667000" indent="-228600">
               <a:lnSpc>
@@ -2197,6 +2259,7 @@
                 <a:spcPts val="1200"/>
               </a:spcAft>
               <a:buChar char="•"/>
+              <a:defRPr/>
             </a:lvl9pPr>
           </a:lstStyle>
           <a:p xmlns:a="http://schemas.openxmlformats.org/drawingml/2006/main"/>
@@ -2258,6 +2321,7 @@
                 <a:spcPts val="1200"/>
               </a:spcAft>
               <a:buChar char="•"/>
+              <a:defRPr/>
             </a:lvl1pPr>
             <a:lvl2pPr marL="533400" indent="-228600">
               <a:lnSpc>
@@ -2270,6 +2334,7 @@
                 <a:spcPts val="1200"/>
               </a:spcAft>
               <a:buChar char="•"/>
+              <a:defRPr/>
             </a:lvl2pPr>
             <a:lvl3pPr marL="838200" indent="-228600">
               <a:lnSpc>
@@ -2282,6 +2347,7 @@
                 <a:spcPts val="1200"/>
               </a:spcAft>
               <a:buChar char="•"/>
+              <a:defRPr/>
             </a:lvl3pPr>
             <a:lvl4pPr marL="1143000" indent="-228600">
               <a:lnSpc>
@@ -2294,6 +2360,7 @@
                 <a:spcPts val="1200"/>
               </a:spcAft>
               <a:buChar char="•"/>
+              <a:defRPr/>
             </a:lvl4pPr>
             <a:lvl5pPr marL="1447800" indent="-228600">
               <a:lnSpc>
@@ -2306,6 +2373,7 @@
                 <a:spcPts val="1200"/>
               </a:spcAft>
               <a:buChar char="•"/>
+              <a:defRPr/>
             </a:lvl5pPr>
             <a:lvl6pPr marL="1752600" indent="-228600">
               <a:lnSpc>
@@ -2318,6 +2386,7 @@
                 <a:spcPts val="1200"/>
               </a:spcAft>
               <a:buChar char="•"/>
+              <a:defRPr/>
             </a:lvl6pPr>
             <a:lvl7pPr marL="2057400" indent="-228600">
               <a:lnSpc>
@@ -2330,6 +2399,7 @@
                 <a:spcPts val="1200"/>
               </a:spcAft>
               <a:buChar char="•"/>
+              <a:defRPr/>
             </a:lvl7pPr>
             <a:lvl8pPr marL="2362200" indent="-228600">
               <a:lnSpc>
@@ -2342,6 +2412,7 @@
                 <a:spcPts val="1200"/>
               </a:spcAft>
               <a:buChar char="•"/>
+              <a:defRPr/>
             </a:lvl8pPr>
             <a:lvl9pPr marL="2667000" indent="-228600">
               <a:lnSpc>
@@ -2354,6 +2425,7 @@
                 <a:spcPts val="1200"/>
               </a:spcAft>
               <a:buChar char="•"/>
+              <a:defRPr/>
             </a:lvl9pPr>
           </a:lstStyle>
           <a:p xmlns:a="http://schemas.openxmlformats.org/drawingml/2006/main"/>
@@ -2432,6 +2504,7 @@
                 <a:spcPts val="0"/>
               </a:spcAft>
               <a:buNone/>
+              <a:defRPr/>
             </a:lvl1pPr>
             <a:lvl2pPr marL="0" indent="0">
               <a:lnSpc>
@@ -2444,6 +2517,7 @@
                 <a:spcPts val="0"/>
               </a:spcAft>
               <a:buNone/>
+              <a:defRPr/>
             </a:lvl2pPr>
             <a:lvl3pPr marL="0" indent="0">
               <a:lnSpc>
@@ -2456,6 +2530,7 @@
                 <a:spcPts val="0"/>
               </a:spcAft>
               <a:buNone/>
+              <a:defRPr/>
             </a:lvl3pPr>
             <a:lvl4pPr marL="0" indent="0">
               <a:lnSpc>
@@ -2468,6 +2543,7 @@
                 <a:spcPts val="0"/>
               </a:spcAft>
               <a:buNone/>
+              <a:defRPr/>
             </a:lvl4pPr>
             <a:lvl5pPr marL="0" indent="0">
               <a:lnSpc>
@@ -2480,6 +2556,7 @@
                 <a:spcPts val="0"/>
               </a:spcAft>
               <a:buNone/>
+              <a:defRPr/>
             </a:lvl5pPr>
             <a:lvl6pPr marL="0" indent="0">
               <a:lnSpc>
@@ -2492,6 +2569,7 @@
                 <a:spcPts val="0"/>
               </a:spcAft>
               <a:buNone/>
+              <a:defRPr/>
             </a:lvl6pPr>
             <a:lvl7pPr marL="0" indent="0">
               <a:lnSpc>
@@ -2504,6 +2582,7 @@
                 <a:spcPts val="0"/>
               </a:spcAft>
               <a:buNone/>
+              <a:defRPr/>
             </a:lvl7pPr>
             <a:lvl8pPr marL="0" indent="0">
               <a:lnSpc>
@@ -2516,6 +2595,7 @@
                 <a:spcPts val="0"/>
               </a:spcAft>
               <a:buNone/>
+              <a:defRPr/>
             </a:lvl8pPr>
             <a:lvl9pPr marL="0" indent="0">
               <a:lnSpc>
@@ -2528,6 +2608,7 @@
                 <a:spcPts val="0"/>
               </a:spcAft>
               <a:buNone/>
+              <a:defRPr/>
             </a:lvl9pPr>
           </a:lstStyle>
           <a:p xmlns:a="http://schemas.openxmlformats.org/drawingml/2006/main"/>
@@ -2589,6 +2670,7 @@
                 <a:spcPts val="1200"/>
               </a:spcAft>
               <a:buChar char="•"/>
+              <a:defRPr/>
             </a:lvl1pPr>
             <a:lvl2pPr marL="533400" indent="-228600">
               <a:lnSpc>
@@ -2601,6 +2683,7 @@
                 <a:spcPts val="1200"/>
               </a:spcAft>
               <a:buChar char="•"/>
+              <a:defRPr/>
             </a:lvl2pPr>
             <a:lvl3pPr marL="838200" indent="-228600">
               <a:lnSpc>
@@ -2613,6 +2696,7 @@
                 <a:spcPts val="1200"/>
               </a:spcAft>
               <a:buChar char="•"/>
+              <a:defRPr/>
             </a:lvl3pPr>
             <a:lvl4pPr marL="1143000" indent="-228600">
               <a:lnSpc>
@@ -2625,6 +2709,7 @@
                 <a:spcPts val="1200"/>
               </a:spcAft>
               <a:buChar char="•"/>
+              <a:defRPr/>
             </a:lvl4pPr>
             <a:lvl5pPr marL="1447800" indent="-228600">
               <a:lnSpc>
@@ -2637,6 +2722,7 @@
                 <a:spcPts val="1200"/>
               </a:spcAft>
               <a:buChar char="•"/>
+              <a:defRPr/>
             </a:lvl5pPr>
             <a:lvl6pPr marL="1752600" indent="-228600">
               <a:lnSpc>
@@ -2649,6 +2735,7 @@
                 <a:spcPts val="1200"/>
               </a:spcAft>
               <a:buChar char="•"/>
+              <a:defRPr/>
             </a:lvl6pPr>
             <a:lvl7pPr marL="2057400" indent="-228600">
               <a:lnSpc>
@@ -2661,6 +2748,7 @@
                 <a:spcPts val="1200"/>
               </a:spcAft>
               <a:buChar char="•"/>
+              <a:defRPr/>
             </a:lvl7pPr>
             <a:lvl8pPr marL="2362200" indent="-228600">
               <a:lnSpc>
@@ -2673,6 +2761,7 @@
                 <a:spcPts val="1200"/>
               </a:spcAft>
               <a:buChar char="•"/>
+              <a:defRPr/>
             </a:lvl8pPr>
             <a:lvl9pPr marL="2667000" indent="-228600">
               <a:lnSpc>
@@ -2685,6 +2774,7 @@
                 <a:spcPts val="1200"/>
               </a:spcAft>
               <a:buChar char="•"/>
+              <a:defRPr/>
             </a:lvl9pPr>
           </a:lstStyle>
           <a:p xmlns:a="http://schemas.openxmlformats.org/drawingml/2006/main"/>
@@ -2733,12 +2823,12 @@
   </p:cSld>
   <p:clrMap bg1="lt1" tx1="dk1" bg2="lt2" tx2="dk2" accent1="accent1" accent2="accent2" accent3="accent3" accent4="accent4" accent5="accent5" accent6="accent6" hlink="hlink" folHlink="folHlink"/>
   <p:sldLayoutIdLst>
-    <p:sldLayoutId xmlns:r="http://schemas.openxmlformats.org/officeDocument/2006/relationships" id="2147483649" r:id="Rb8c06e34a4654895"/>
-    <p:sldLayoutId xmlns:r="http://schemas.openxmlformats.org/officeDocument/2006/relationships" id="2147483650" r:id="R5241afcf49364afd"/>
-    <p:sldLayoutId xmlns:r="http://schemas.openxmlformats.org/officeDocument/2006/relationships" id="2147483651" r:id="Rceba5749dc854f4a"/>
-    <p:sldLayoutId xmlns:r="http://schemas.openxmlformats.org/officeDocument/2006/relationships" id="2147483652" r:id="R27df871f590c4660"/>
-    <p:sldLayoutId xmlns:r="http://schemas.openxmlformats.org/officeDocument/2006/relationships" id="2147483653" r:id="R1d8348a017e34c27"/>
-    <p:sldLayoutId xmlns:r="http://schemas.openxmlformats.org/officeDocument/2006/relationships" id="2147483654" r:id="Rbc5b8f3f004741e2"/>
+    <p:sldLayoutId xmlns:r="http://schemas.openxmlformats.org/officeDocument/2006/relationships" id="2147483649" r:id="Rf4f179eaa97346bf"/>
+    <p:sldLayoutId xmlns:r="http://schemas.openxmlformats.org/officeDocument/2006/relationships" id="2147483650" r:id="Rad895cfae2454cd5"/>
+    <p:sldLayoutId xmlns:r="http://schemas.openxmlformats.org/officeDocument/2006/relationships" id="2147483651" r:id="R77dd26f8894942f3"/>
+    <p:sldLayoutId xmlns:r="http://schemas.openxmlformats.org/officeDocument/2006/relationships" id="2147483652" r:id="Rf51287e2312c4aa5"/>
+    <p:sldLayoutId xmlns:r="http://schemas.openxmlformats.org/officeDocument/2006/relationships" id="2147483653" r:id="R98076215252b4d07"/>
+    <p:sldLayoutId xmlns:r="http://schemas.openxmlformats.org/officeDocument/2006/relationships" id="2147483654" r:id="R1f5a2d6935d4474a"/>
   </p:sldLayoutIdLst>
   <p:txStyles>
     <p:titleStyle>
@@ -3330,6 +3420,7 @@
           </a:lstStyle>
           <a:p xmlns:a="http://schemas.openxmlformats.org/drawingml/2006/main">
             <a:pPr algn="l">
+              <a:buNone/>
               <a:defRPr sz="5400" b="1">
                 <a:solidFill>
                   <a:srgbClr val="FFFFFF"/>
@@ -3399,6 +3490,7 @@
           </a:lstStyle>
           <a:p xmlns:a="http://schemas.openxmlformats.org/drawingml/2006/main">
             <a:pPr algn="l">
+              <a:buNone/>
               <a:defRPr sz="2550">
                 <a:solidFill>
                   <a:srgbClr val="D7E6F7"/>
@@ -3468,6 +3560,7 @@
           </a:lstStyle>
           <a:p xmlns:a="http://schemas.openxmlformats.org/drawingml/2006/main">
             <a:pPr algn="l">
+              <a:buNone/>
               <a:defRPr sz="1725">
                 <a:solidFill>
                   <a:srgbClr val="D7E6F7"/>
@@ -3566,6 +3659,7 @@
           </a:lstStyle>
           <a:p xmlns:a="http://schemas.openxmlformats.org/drawingml/2006/main">
             <a:pPr algn="l">
+              <a:buNone/>
               <a:defRPr sz="3450" b="1">
                 <a:solidFill>
                   <a:srgbClr val="0B1F3A"/>
@@ -3635,6 +3729,7 @@
           </a:lstStyle>
           <a:p xmlns:a="http://schemas.openxmlformats.org/drawingml/2006/main">
             <a:pPr algn="l">
+              <a:buNone/>
               <a:defRPr sz="2175" b="1">
                 <a:solidFill>
                   <a:srgbClr val="142033"/>
@@ -3704,6 +3799,7 @@
           </a:lstStyle>
           <a:p xmlns:a="http://schemas.openxmlformats.org/drawingml/2006/main">
             <a:pPr algn="l">
+              <a:buNone/>
               <a:defRPr sz="1800">
                 <a:solidFill>
                   <a:srgbClr val="526174"/>
@@ -3732,7 +3828,7 @@
           <p:cNvPr id="4" name="">
             <a:extLst xmlns:a="http://schemas.openxmlformats.org/drawingml/2006/main">
               <a:ext uri="{FF2B5EF4-FFF2-40B4-BE49-F238E27FC236}">
-                <a16:creationId xmlns:a16="http://schemas.microsoft.com/office/drawing/2014/main" id="{71230DEA-48B0-4760-969E-508A50D7DA52}"/>
+                <a16:creationId xmlns:a16="http://schemas.microsoft.com/office/drawing/2014/main" id="{3F8AEE42-E828-4634-9127-06B1B4E05D44}"/>
               </a:ext>
             </a:extLst>
           </p:cNvPr>
@@ -3742,7 +3838,7 @@
           <p:nvPr/>
         </p:nvPicPr>
         <p:blipFill>
-          <a:blip xmlns:r="http://schemas.openxmlformats.org/officeDocument/2006/relationships" xmlns:a="http://schemas.openxmlformats.org/drawingml/2006/main" r:embed="R696a46c930104989"/>
+          <a:blip xmlns:r="http://schemas.openxmlformats.org/officeDocument/2006/relationships" xmlns:a="http://schemas.openxmlformats.org/drawingml/2006/main" r:embed="R82486c023e9c43a2"/>
           <a:stretch xmlns:a="http://schemas.openxmlformats.org/drawingml/2006/main"/>
         </p:blipFill>
         <p:spPr>
@@ -3789,7 +3885,7 @@
           <p:cNvPr id="9" name="">
             <a:extLst xmlns:a="http://schemas.openxmlformats.org/drawingml/2006/main">
               <a:ext uri="{FF2B5EF4-FFF2-40B4-BE49-F238E27FC236}">
-                <a16:creationId xmlns:a16="http://schemas.microsoft.com/office/drawing/2014/main" id="{3B303836-AB17-4F13-9C17-67D2BC8A2534}"/>
+                <a16:creationId xmlns:a16="http://schemas.microsoft.com/office/drawing/2014/main" id="{3933C9BF-8191-442E-A681-A6432579856B}"/>
               </a:ext>
             </a:extLst>
           </p:cNvPr>
@@ -3821,7 +3917,7 @@
           <p:cNvPr id="8" name="">
             <a:extLst xmlns:a="http://schemas.openxmlformats.org/drawingml/2006/main">
               <a:ext uri="{FF2B5EF4-FFF2-40B4-BE49-F238E27FC236}">
-                <a16:creationId xmlns:a16="http://schemas.microsoft.com/office/drawing/2014/main" id="{0CADEB2A-3042-4F7D-BC02-7912AF8791D3}"/>
+                <a16:creationId xmlns:a16="http://schemas.microsoft.com/office/drawing/2014/main" id="{5829F6B6-21F4-446F-ABEF-2B6897F6D821}"/>
               </a:ext>
             </a:extLst>
           </p:cNvPr>
@@ -3853,7 +3949,7 @@
           <p:cNvPr id="7" name="">
             <a:extLst xmlns:a="http://schemas.openxmlformats.org/drawingml/2006/main">
               <a:ext uri="{FF2B5EF4-FFF2-40B4-BE49-F238E27FC236}">
-                <a16:creationId xmlns:a16="http://schemas.microsoft.com/office/drawing/2014/main" id="{0CE1EDAA-1508-4B4E-B4E7-F748832130A1}"/>
+                <a16:creationId xmlns:a16="http://schemas.microsoft.com/office/drawing/2014/main" id="{70F39450-2E3C-448E-B972-FD712D7ACEB1}"/>
               </a:ext>
             </a:extLst>
           </p:cNvPr>
@@ -3926,6 +4022,7 @@
           </a:lstStyle>
           <a:p xmlns:a="http://schemas.openxmlformats.org/drawingml/2006/main">
             <a:pPr algn="l">
+              <a:buNone/>
               <a:defRPr sz="3450" b="1">
                 <a:solidFill>
                   <a:srgbClr val="0B1F3A"/>
@@ -3995,6 +4092,7 @@
           </a:lstStyle>
           <a:p xmlns:a="http://schemas.openxmlformats.org/drawingml/2006/main">
             <a:pPr algn="l">
+              <a:buNone/>
               <a:defRPr sz="1875">
                 <a:solidFill>
                   <a:srgbClr val="526174"/>
@@ -4070,6 +4168,7 @@
           </a:lstStyle>
           <a:p xmlns:a="http://schemas.openxmlformats.org/drawingml/2006/main">
             <a:pPr algn="ctr">
+              <a:buNone/>
               <a:defRPr sz="1800" b="1">
                 <a:solidFill>
                   <a:srgbClr val="0B1F3A"/>
@@ -4145,6 +4244,7 @@
           </a:lstStyle>
           <a:p xmlns:a="http://schemas.openxmlformats.org/drawingml/2006/main">
             <a:pPr algn="ctr">
+              <a:buNone/>
               <a:defRPr sz="1800" b="1">
                 <a:solidFill>
                   <a:srgbClr val="0B1F3A"/>
@@ -4168,6 +4268,7 @@
           </a:p>
           <a:p xmlns:a="http://schemas.openxmlformats.org/drawingml/2006/main">
             <a:pPr algn="ctr">
+              <a:buNone/>
               <a:defRPr sz="1800" b="1">
                 <a:solidFill>
                   <a:srgbClr val="0B1F3A"/>
@@ -4243,6 +4344,7 @@
           </a:lstStyle>
           <a:p xmlns:a="http://schemas.openxmlformats.org/drawingml/2006/main">
             <a:pPr algn="ctr">
+              <a:buNone/>
               <a:defRPr sz="1800" b="1">
                 <a:solidFill>
                   <a:srgbClr val="0B1F3A"/>
@@ -4266,6 +4368,7 @@
           </a:p>
           <a:p xmlns:a="http://schemas.openxmlformats.org/drawingml/2006/main">
             <a:pPr algn="ctr">
+              <a:buNone/>
               <a:defRPr sz="1800" b="1">
                 <a:solidFill>
                   <a:srgbClr val="0B1F3A"/>
@@ -4341,6 +4444,7 @@
           </a:lstStyle>
           <a:p xmlns:a="http://schemas.openxmlformats.org/drawingml/2006/main">
             <a:pPr algn="ctr">
+              <a:buNone/>
               <a:defRPr sz="1800" b="1">
                 <a:solidFill>
                   <a:srgbClr val="0B1F3A"/>
@@ -4364,6 +4468,7 @@
           </a:p>
           <a:p xmlns:a="http://schemas.openxmlformats.org/drawingml/2006/main">
             <a:pPr algn="ctr">
+              <a:buNone/>
               <a:defRPr sz="1800" b="1">
                 <a:solidFill>
                   <a:srgbClr val="0B1F3A"/>
@@ -4433,6 +4538,7 @@
           </a:lstStyle>
           <a:p xmlns:a="http://schemas.openxmlformats.org/drawingml/2006/main">
             <a:pPr algn="ctr">
+              <a:buNone/>
               <a:defRPr sz="2175" b="1">
                 <a:solidFill>
                   <a:srgbClr val="0F766E"/>
@@ -4502,6 +4608,7 @@
           </a:lstStyle>
           <a:p xmlns:a="http://schemas.openxmlformats.org/drawingml/2006/main">
             <a:pPr algn="ctr">
+              <a:buNone/>
               <a:defRPr sz="1650">
                 <a:solidFill>
                   <a:srgbClr val="526174"/>
@@ -4600,6 +4707,7 @@
           </a:lstStyle>
           <a:p xmlns:a="http://schemas.openxmlformats.org/drawingml/2006/main">
             <a:pPr algn="l">
+              <a:buNone/>
               <a:defRPr sz="3450" b="1">
                 <a:solidFill>
                   <a:srgbClr val="0B1F3A"/>
@@ -4628,7 +4736,7 @@
           <p:cNvPr id="2" name="">
             <a:extLst xmlns:a="http://schemas.openxmlformats.org/drawingml/2006/main">
               <a:ext uri="{FF2B5EF4-FFF2-40B4-BE49-F238E27FC236}">
-                <a16:creationId xmlns:a16="http://schemas.microsoft.com/office/drawing/2014/main" id="{27C15C7D-7B25-4154-A4C8-E8CF9FC80A18}"/>
+                <a16:creationId xmlns:a16="http://schemas.microsoft.com/office/drawing/2014/main" id="{ADA7F3FA-8DA5-4B7C-966D-7F660C747316}"/>
               </a:ext>
             </a:extLst>
           </p:cNvPr>
@@ -4638,7 +4746,7 @@
           <p:nvPr/>
         </p:nvPicPr>
         <p:blipFill>
-          <a:blip xmlns:r="http://schemas.openxmlformats.org/officeDocument/2006/relationships" xmlns:a="http://schemas.openxmlformats.org/drawingml/2006/main" r:embed="R291410d6b50f4ca2"/>
+          <a:blip xmlns:r="http://schemas.openxmlformats.org/officeDocument/2006/relationships" xmlns:a="http://schemas.openxmlformats.org/drawingml/2006/main" r:embed="Rb2a5a5deb95e40a6"/>
           <a:stretch xmlns:a="http://schemas.openxmlformats.org/drawingml/2006/main"/>
         </p:blipFill>
         <p:spPr>
@@ -4697,6 +4805,7 @@
           </a:lstStyle>
           <a:p xmlns:a="http://schemas.openxmlformats.org/drawingml/2006/main">
             <a:pPr algn="l">
+              <a:buNone/>
               <a:defRPr sz="3000" b="1">
                 <a:solidFill>
                   <a:srgbClr val="1D4ED8"/>
@@ -4766,6 +4875,7 @@
           </a:lstStyle>
           <a:p xmlns:a="http://schemas.openxmlformats.org/drawingml/2006/main">
             <a:pPr algn="l">
+              <a:buNone/>
               <a:defRPr sz="1800">
                 <a:solidFill>
                   <a:srgbClr val="142033"/>
@@ -4835,6 +4945,7 @@
           </a:lstStyle>
           <a:p xmlns:a="http://schemas.openxmlformats.org/drawingml/2006/main">
             <a:pPr algn="l">
+              <a:buNone/>
               <a:defRPr sz="1650" b="1">
                 <a:solidFill>
                   <a:srgbClr val="C2410C"/>
@@ -4933,6 +5044,7 @@
           </a:lstStyle>
           <a:p xmlns:a="http://schemas.openxmlformats.org/drawingml/2006/main">
             <a:pPr algn="l">
+              <a:buNone/>
               <a:defRPr sz="3450" b="1">
                 <a:solidFill>
                   <a:srgbClr val="0B1F3A"/>
@@ -5002,6 +5114,7 @@
           </a:lstStyle>
           <a:p xmlns:a="http://schemas.openxmlformats.org/drawingml/2006/main">
             <a:pPr algn="l">
+              <a:buNone/>
               <a:defRPr sz="2325" b="1">
                 <a:solidFill>
                   <a:srgbClr val="142033"/>
@@ -5071,6 +5184,7 @@
           </a:lstStyle>
           <a:p xmlns:a="http://schemas.openxmlformats.org/drawingml/2006/main">
             <a:pPr algn="l">
+              <a:buNone/>
               <a:defRPr sz="1875">
                 <a:solidFill>
                   <a:srgbClr val="526174"/>
@@ -5140,6 +5254,7 @@
           </a:lstStyle>
           <a:p xmlns:a="http://schemas.openxmlformats.org/drawingml/2006/main">
             <a:pPr algn="l">
+              <a:buNone/>
               <a:defRPr sz="1875">
                 <a:solidFill>
                   <a:srgbClr val="526174"/>
@@ -5209,6 +5324,7 @@
           </a:lstStyle>
           <a:p xmlns:a="http://schemas.openxmlformats.org/drawingml/2006/main">
             <a:pPr algn="l">
+              <a:buNone/>
               <a:defRPr sz="1650" b="1">
                 <a:solidFill>
                   <a:srgbClr val="C2410C"/>
@@ -5232,6 +5348,7 @@
           </a:p>
           <a:p xmlns:a="http://schemas.openxmlformats.org/drawingml/2006/main">
             <a:pPr algn="l">
+              <a:buNone/>
               <a:defRPr sz="1650" b="1">
                 <a:solidFill>
                   <a:srgbClr val="C2410C"/>
@@ -5330,6 +5447,7 @@
           </a:lstStyle>
           <a:p xmlns:a="http://schemas.openxmlformats.org/drawingml/2006/main">
             <a:pPr algn="l">
+              <a:buNone/>
               <a:defRPr sz="3450" b="1">
                 <a:solidFill>
                   <a:srgbClr val="0B1F3A"/>
@@ -5399,6 +5517,7 @@
           </a:lstStyle>
           <a:p xmlns:a="http://schemas.openxmlformats.org/drawingml/2006/main">
             <a:pPr algn="l">
+              <a:buNone/>
               <a:defRPr sz="2325" b="1">
                 <a:solidFill>
                   <a:srgbClr val="142033"/>
@@ -5468,6 +5587,7 @@
           </a:lstStyle>
           <a:p xmlns:a="http://schemas.openxmlformats.org/drawingml/2006/main">
             <a:pPr algn="l">
+              <a:buNone/>
               <a:defRPr sz="1875">
                 <a:solidFill>
                   <a:srgbClr val="526174"/>
@@ -5491,6 +5611,7 @@
           </a:p>
           <a:p xmlns:a="http://schemas.openxmlformats.org/drawingml/2006/main">
             <a:pPr algn="l">
+              <a:buNone/>
               <a:defRPr sz="1875">
                 <a:solidFill>
                   <a:srgbClr val="526174"/>
@@ -5514,6 +5635,7 @@
           </a:p>
           <a:p xmlns:a="http://schemas.openxmlformats.org/drawingml/2006/main">
             <a:pPr algn="l">
+              <a:buNone/>
               <a:defRPr sz="1875">
                 <a:solidFill>
                   <a:srgbClr val="526174"/>
@@ -5537,6 +5659,7 @@
           </a:p>
           <a:p xmlns:a="http://schemas.openxmlformats.org/drawingml/2006/main">
             <a:pPr algn="l">
+              <a:buNone/>
               <a:defRPr sz="1875">
                 <a:solidFill>
                   <a:srgbClr val="526174"/>
@@ -5606,6 +5729,7 @@
           </a:lstStyle>
           <a:p xmlns:a="http://schemas.openxmlformats.org/drawingml/2006/main">
             <a:pPr algn="l">
+              <a:buNone/>
               <a:defRPr sz="1575" b="1">
                 <a:solidFill>
                   <a:srgbClr val="C2410C"/>
@@ -5634,7 +5758,7 @@
           <p:cNvPr id="5" name="">
             <a:extLst xmlns:a="http://schemas.openxmlformats.org/drawingml/2006/main">
               <a:ext uri="{FF2B5EF4-FFF2-40B4-BE49-F238E27FC236}">
-                <a16:creationId xmlns:a16="http://schemas.microsoft.com/office/drawing/2014/main" id="{3495ED1C-24EE-45BF-8DEF-8CEF4B270550}"/>
+                <a16:creationId xmlns:a16="http://schemas.microsoft.com/office/drawing/2014/main" id="{EAA1AD99-E11A-493C-8170-41438A3901F1}"/>
               </a:ext>
             </a:extLst>
           </p:cNvPr>
@@ -5644,7 +5768,7 @@
           <p:nvPr/>
         </p:nvPicPr>
         <p:blipFill>
-          <a:blip xmlns:r="http://schemas.openxmlformats.org/officeDocument/2006/relationships" xmlns:a="http://schemas.openxmlformats.org/drawingml/2006/main" r:embed="R19054a1d4d064493"/>
+          <a:blip xmlns:r="http://schemas.openxmlformats.org/officeDocument/2006/relationships" xmlns:a="http://schemas.openxmlformats.org/drawingml/2006/main" r:embed="Rd587d8842e95445c"/>
           <a:stretch xmlns:a="http://schemas.openxmlformats.org/drawingml/2006/main"/>
         </p:blipFill>
         <p:spPr>
@@ -5732,6 +5856,7 @@
           </a:lstStyle>
           <a:p xmlns:a="http://schemas.openxmlformats.org/drawingml/2006/main">
             <a:pPr algn="l">
+              <a:buNone/>
               <a:defRPr sz="3450" b="1">
                 <a:solidFill>
                   <a:srgbClr val="0B1F3A"/>
@@ -5760,7 +5885,7 @@
           <p:cNvPr id="2" name="">
             <a:extLst xmlns:a="http://schemas.openxmlformats.org/drawingml/2006/main">
               <a:ext uri="{FF2B5EF4-FFF2-40B4-BE49-F238E27FC236}">
-                <a16:creationId xmlns:a16="http://schemas.microsoft.com/office/drawing/2014/main" id="{A7A04C52-C605-4D75-896B-44CCFF69F209}"/>
+                <a16:creationId xmlns:a16="http://schemas.microsoft.com/office/drawing/2014/main" id="{B4388E93-8130-479F-AC0C-888E8023B963}"/>
               </a:ext>
             </a:extLst>
           </p:cNvPr>
@@ -5770,7 +5895,7 @@
           <p:nvPr/>
         </p:nvPicPr>
         <p:blipFill>
-          <a:blip xmlns:r="http://schemas.openxmlformats.org/officeDocument/2006/relationships" xmlns:a="http://schemas.openxmlformats.org/drawingml/2006/main" r:embed="R81a245b1a7b84f0f"/>
+          <a:blip xmlns:r="http://schemas.openxmlformats.org/officeDocument/2006/relationships" xmlns:a="http://schemas.openxmlformats.org/drawingml/2006/main" r:embed="R38d9511345ef4e3a"/>
           <a:stretch xmlns:a="http://schemas.openxmlformats.org/drawingml/2006/main"/>
         </p:blipFill>
         <p:spPr>
@@ -5788,7 +5913,7 @@
           <p:cNvPr id="3" name="">
             <a:extLst xmlns:a="http://schemas.openxmlformats.org/drawingml/2006/main">
               <a:ext uri="{FF2B5EF4-FFF2-40B4-BE49-F238E27FC236}">
-                <a16:creationId xmlns:a16="http://schemas.microsoft.com/office/drawing/2014/main" id="{E15CD4C6-CF24-48FC-AA41-E59B362D1A35}"/>
+                <a16:creationId xmlns:a16="http://schemas.microsoft.com/office/drawing/2014/main" id="{F13FF220-D7D3-4C2F-B93C-E9E3183E3FE6}"/>
               </a:ext>
             </a:extLst>
           </p:cNvPr>
@@ -5798,7 +5923,7 @@
           <p:nvPr/>
         </p:nvPicPr>
         <p:blipFill>
-          <a:blip xmlns:r="http://schemas.openxmlformats.org/officeDocument/2006/relationships" xmlns:a="http://schemas.openxmlformats.org/drawingml/2006/main" r:embed="R001a235cf1cc402a"/>
+          <a:blip xmlns:r="http://schemas.openxmlformats.org/officeDocument/2006/relationships" xmlns:a="http://schemas.openxmlformats.org/drawingml/2006/main" r:embed="R5cc81b14a7084549"/>
           <a:stretch xmlns:a="http://schemas.openxmlformats.org/drawingml/2006/main"/>
         </p:blipFill>
         <p:spPr>
@@ -5857,6 +5982,7 @@
           </a:lstStyle>
           <a:p xmlns:a="http://schemas.openxmlformats.org/drawingml/2006/main">
             <a:pPr algn="ctr">
+              <a:buNone/>
               <a:defRPr sz="1800" b="1">
                 <a:solidFill>
                   <a:srgbClr val="142033"/>
@@ -5955,6 +6081,7 @@
           </a:lstStyle>
           <a:p xmlns:a="http://schemas.openxmlformats.org/drawingml/2006/main">
             <a:pPr algn="l">
+              <a:buNone/>
               <a:defRPr sz="3450" b="1">
                 <a:solidFill>
                   <a:srgbClr val="0B1F3A"/>
@@ -6024,6 +6151,7 @@
           </a:lstStyle>
           <a:p xmlns:a="http://schemas.openxmlformats.org/drawingml/2006/main">
             <a:pPr algn="l">
+              <a:buNone/>
               <a:defRPr sz="1950" b="1">
                 <a:solidFill>
                   <a:srgbClr val="0B1F3A"/>
@@ -6047,6 +6175,7 @@
           </a:p>
           <a:p xmlns:a="http://schemas.openxmlformats.org/drawingml/2006/main">
             <a:pPr algn="l">
+              <a:buNone/>
               <a:defRPr sz="1950" b="1">
                 <a:solidFill>
                   <a:srgbClr val="0B1F3A"/>
@@ -6116,6 +6245,7 @@
           </a:lstStyle>
           <a:p xmlns:a="http://schemas.openxmlformats.org/drawingml/2006/main">
             <a:pPr algn="l">
+              <a:buNone/>
               <a:defRPr sz="1800">
                 <a:solidFill>
                   <a:srgbClr val="142033"/>
@@ -6185,6 +6315,7 @@
           </a:lstStyle>
           <a:p xmlns:a="http://schemas.openxmlformats.org/drawingml/2006/main">
             <a:pPr algn="l">
+              <a:buNone/>
               <a:defRPr sz="1875" b="1">
                 <a:solidFill>
                   <a:srgbClr val="C2410C"/>
@@ -6254,6 +6385,7 @@
           </a:lstStyle>
           <a:p xmlns:a="http://schemas.openxmlformats.org/drawingml/2006/main">
             <a:pPr algn="l">
+              <a:buNone/>
               <a:defRPr sz="1725">
                 <a:solidFill>
                   <a:srgbClr val="526174"/>
@@ -6352,6 +6484,7 @@
           </a:lstStyle>
           <a:p xmlns:a="http://schemas.openxmlformats.org/drawingml/2006/main">
             <a:pPr algn="l">
+              <a:buNone/>
               <a:defRPr sz="3600" b="1">
                 <a:solidFill>
                   <a:srgbClr val="FFFFFF"/>
@@ -6370,7 +6503,7 @@
                 <a:ea typeface="Arial"/>
                 <a:cs typeface="Arial"/>
               </a:rPr>
-              <a:t>Cloud deployment remains pending</a:t>
+              <a:t>CI is green; AWS deployment is next</a:t>
             </a:r>
           </a:p>
         </p:txBody>
@@ -6421,6 +6554,7 @@
           </a:lstStyle>
           <a:p xmlns:a="http://schemas.openxmlformats.org/drawingml/2006/main">
             <a:pPr algn="l">
+              <a:buNone/>
               <a:defRPr sz="2025">
                 <a:solidFill>
                   <a:srgbClr val="D7E6F7"/>
@@ -6439,7 +6573,7 @@
                 <a:ea typeface="Arial"/>
                 <a:cs typeface="Arial"/>
               </a:rPr>
-              <a:t>Terraform configuration is present and `fmt`, `init`, and `validate` passed. There is no AWS account configured, so no plan, apply, EKS deployment, or destroy was performed.</a:t>
+              <a:t>Terraform `fmt`, `init`, and `validate` passed. AWS credentials are not connected to this workspace, so plan, apply, EKS deployment, and destroy have not run.</a:t>
             </a:r>
           </a:p>
         </p:txBody>
@@ -6490,6 +6624,7 @@
           </a:lstStyle>
           <a:p xmlns:a="http://schemas.openxmlformats.org/drawingml/2006/main">
             <a:pPr algn="l">
+              <a:buNone/>
               <a:defRPr sz="2025">
                 <a:solidFill>
                   <a:srgbClr val="FFFFFF"/>
@@ -6508,7 +6643,7 @@
                 <a:ea typeface="Arial"/>
                 <a:cs typeface="Arial"/>
               </a:rPr>
-              <a:t>For the recorded walkthrough: show the working app, Compose services, tests, Minikube Ingress, Prometheus, and Grafana. State clearly that the GitHub Actions run and AWS deployment are still pending.</a:t>
+              <a:t>Run #4 passed tests, the frontend build, and both Trivy scans. Public SHA-tagged images were published to GHCR. Deployment skipped because the workflow deploys only from main. Next: connect AWS and deploy to EKS with Helm.</a:t>
             </a:r>
           </a:p>
         </p:txBody>
@@ -6559,6 +6694,7 @@
           </a:lstStyle>
           <a:p xmlns:a="http://schemas.openxmlformats.org/drawingml/2006/main">
             <a:pPr algn="l">
+              <a:buNone/>
               <a:defRPr sz="1725" b="1">
                 <a:solidFill>
                   <a:srgbClr val="92D9D0"/>

</xml_diff>